<commit_message>
Dokumentacja i pozostale teksty bez dlugich myslnikow (#15)
376 wystapien w 16 plikach: dokumentacja, README, konfiguracja CI, worker
Cloudflare, strona bledu bramy OpenSEO i tresc slajdow. Prezentacje
przebudowane ze zmienionego zrodla, zeby wersjonowane pptx nie rozjechaly
sie z tekstem, z ktorego powstaja.

Kontrola audyt_myslniki.py zostaje w repo i wchodzi do CI. Sprawdzone,
ze lapie nawrot: po wstrzyknieciu jednego myslnika konczy kodem 1.

Dwie wlasne usterki przy pisaniu tej kontroli, obie naprawione. Skrypt
zjadl wlasny ogon - jest plikiem .py w skanowanym drzewie, wiec podmienil
myslniki we wlasnej definicji i zaczal zglaszac kazdy lacznik w repo.
Katalog .github wypadal z kontroli, bo ".git" jest podciagiem ".github";
po poprawieniu porownania na czlony sciezki wyszlo szesc myslnikow
w samym pliku CI.

Chronione wyrazenie regularne w aplikacji przetrwalo bez zmian.
</commit_message>
<xml_diff>
--- a/prezentacje/EN/ContentAI_Security_EN.pptx
+++ b/prezentacje/EN/ContentAI_Security_EN.pptx
@@ -3021,7 +3021,7 @@
                 <a:ea typeface="Arial" pitchFamily="34" charset="-122"/>
                 <a:cs typeface="Arial" pitchFamily="34" charset="-120"/>
               </a:rPr>
-              <a:t>An administrator changes passwords by command — there is no self-service.</a:t>
+              <a:t>An administrator changes passwords by command - there is no self-service.</a:t>
             </a:r>
             <a:endParaRPr lang="en-US" sz="950" dirty="0"/>
           </a:p>
@@ -3336,7 +3336,7 @@
                 <a:ea typeface="Arial" pitchFamily="34" charset="-122"/>
                 <a:cs typeface="Arial" pitchFamily="34" charset="-120"/>
               </a:rPr>
-              <a:t>With the gateway, port 3100 must not be exposed — the identity header would be forgeable.</a:t>
+              <a:t>With the gateway, port 3100 must not be exposed - the identity header would be forgeable.</a:t>
             </a:r>
             <a:endParaRPr lang="en-US" sz="950" dirty="0"/>
           </a:p>
@@ -4361,7 +4361,7 @@
                 <a:ea typeface="Arial" pitchFamily="34" charset="-122"/>
                 <a:cs typeface="Arial" pitchFamily="34" charset="-120"/>
               </a:rPr>
-              <a:t>serwer/dane/ holds accounts and the knowledge base — the only data git cannot restore.</a:t>
+              <a:t>serwer/dane/ holds accounts and the knowledge base - the only data git cannot restore.</a:t>
             </a:r>
             <a:endParaRPr lang="en-US" sz="950" dirty="0"/>
           </a:p>
@@ -5208,7 +5208,7 @@
                 <a:ea typeface="Arial" pitchFamily="34" charset="-122"/>
                 <a:cs typeface="Arial" pitchFamily="34" charset="-120"/>
               </a:rPr>
-              <a:t>a browser fingerprint — gone once site data is cleared</a:t>
+              <a:t>a browser fingerprint - gone once site data is cleared</a:t>
             </a:r>
             <a:endParaRPr lang="en-US" sz="950" dirty="0"/>
           </a:p>
@@ -6614,7 +6614,7 @@
                 <a:ea typeface="Arial" pitchFamily="34" charset="-122"/>
                 <a:cs typeface="Arial" pitchFamily="34" charset="-120"/>
               </a:rPr>
-              <a:t>The server runs on your machine — a systemd unit with restricted privileges, writing only to the accounts directory</a:t>
+              <a:t>The server runs on your machine - a systemd unit with restricted privileges, writing only to the accounts directory</a:t>
             </a:r>
             <a:endParaRPr lang="en-US" sz="1100" dirty="0"/>
           </a:p>
@@ -8371,7 +8371,7 @@
                 <a:ea typeface="Arial" pitchFamily="34" charset="-122"/>
                 <a:cs typeface="Arial" pitchFamily="34" charset="-120"/>
               </a:rPr>
-              <a:t>nothing — the app calls your server, which attaches the key</a:t>
+              <a:t>nothing - the app calls your server, which attaches the key</a:t>
             </a:r>
             <a:endParaRPr lang="en-US" sz="1050" dirty="0"/>
           </a:p>
@@ -8581,7 +8581,7 @@
                 <a:ea typeface="Arial" pitchFamily="34" charset="-122"/>
                 <a:cs typeface="Arial" pitchFamily="34" charset="-120"/>
               </a:rPr>
-              <a:t>an admin endpoint reports whether a key is set — never its value</a:t>
+              <a:t>an admin endpoint reports whether a key is set - never its value</a:t>
             </a:r>
             <a:endParaRPr lang="en-US" sz="1050" dirty="0"/>
           </a:p>
@@ -9318,7 +9318,7 @@
                 <a:ea typeface="Arial" pitchFamily="34" charset="-122"/>
                 <a:cs typeface="Arial" pitchFamily="34" charset="-120"/>
               </a:rPr>
-              <a:t>Only passages matching the topic reach the prompt, not the whole base — less data leaves the organisation than when whole documents were pasted in.</a:t>
+              <a:t>Only passages matching the topic reach the prompt, not the whole base - less data leaves the organisation than when whole documents were pasted in.</a:t>
             </a:r>
             <a:endParaRPr lang="en-US" sz="1050" dirty="0"/>
           </a:p>
@@ -9835,7 +9835,7 @@
                 <a:ea typeface="Arial" pitchFamily="34" charset="-122"/>
                 <a:cs typeface="Arial" pitchFamily="34" charset="-120"/>
               </a:rPr>
-              <a:t>The filename derives from the login passed through a character filter — directory traversal is not possible</a:t>
+              <a:t>The filename derives from the login passed through a character filter - directory traversal is not possible</a:t>
             </a:r>
             <a:endParaRPr lang="en-US" sz="1100" dirty="0"/>
           </a:p>
@@ -10207,7 +10207,7 @@
                 <a:ea typeface="Arial" pitchFamily="34" charset="-122"/>
                 <a:cs typeface="Arial" pitchFamily="34" charset="-120"/>
               </a:rPr>
-              <a:t>the containerised OpenSEO starts with no login at all — exposed directly it grants full access to anyone who knows the address</a:t>
+              <a:t>the containerised OpenSEO starts with no login at all - exposed directly it grants full access to anyone who knows the address</a:t>
             </a:r>
             <a:endParaRPr lang="en-US" sz="1050" dirty="0"/>
           </a:p>

</xml_diff>